<commit_message>
hs-web: 선 그림 코드 덱 8개 다시 굽기 (deckgen v2.1.2 art 모드)
Co-Authored-By: Claude Opus 5.5 <noreply@anthropic.com>
</commit_message>
<xml_diff>
--- a/hs-web/T06_브라우저와_DOM_이벤트_모델.pptx
+++ b/hs-web/T06_브라우저와_DOM_이벤트_모델.pptx
@@ -5573,334 +5573,30 @@
           </a:p>
         </p:txBody>
       </p:sp>
-      <p:sp>
-        <p:nvSpPr>
-          <p:cNvPr id="11" name="deckgen:code"/>
-          <p:cNvSpPr txBox="1"/>
-          <p:nvPr/>
-        </p:nvSpPr>
+      <p:pic>
+        <p:nvPicPr>
+          <p:cNvPr id="11" name="deckgen:code-art" descr="image.png"/>
+          <p:cNvPicPr>
+            <a:picLocks noChangeAspect="1"/>
+          </p:cNvPicPr>
+          <p:nvPr/>
+        </p:nvPicPr>
+        <p:blipFill>
+          <a:blip r:embed="rId2"/>
+          <a:stretch>
+            <a:fillRect/>
+          </a:stretch>
+        </p:blipFill>
         <p:spPr>
           <a:xfrm>
             <a:off x="2038350" y="2552700"/>
-            <a:ext cx="14897100" cy="5105400"/>
-          </a:xfrm>
-          <a:prstGeom prst="rect">
-            <a:avLst/>
-          </a:prstGeom>
-          <a:noFill/>
-        </p:spPr>
-        <p:txBody>
-          <a:bodyPr wrap="none" lIns="0" rIns="0" tIns="0" bIns="0" anchor="t">
-            <a:spAutoFit/>
-          </a:bodyPr>
-          <a:lstStyle/>
-          <a:p>
-            <a:pPr algn="l">
-              <a:lnSpc>
-                <a:spcPct val="115000"/>
-              </a:lnSpc>
-            </a:pPr>
-            <a:r>
-              <a:rPr sz="2250" b="0">
-                <a:solidFill>
-                  <a:srgbClr val="8ABFFF"/>
-                </a:solidFill>
-                <a:latin typeface="나눔고딕코딩"/>
-                <a:ea typeface="나눔고딕코딩"/>
-                <a:cs typeface="나눔고딕코딩"/>
-              </a:rPr>
-              <a:t>&lt;p</a:t>
-            </a:r>
-            <a:r>
-              <a:rPr sz="2250" b="0">
-                <a:solidFill>
-                  <a:srgbClr val="8ABFFF"/>
-                </a:solidFill>
-                <a:latin typeface="나눔고딕코딩"/>
-                <a:ea typeface="나눔고딕코딩"/>
-                <a:cs typeface="나눔고딕코딩"/>
-              </a:rPr>
-              <a:t>&gt;</a:t>
-            </a:r>
-            <a:r>
-              <a:rPr sz="2250" b="0">
-                <a:solidFill>
-                  <a:srgbClr val="E6EAF2"/>
-                </a:solidFill>
-                <a:latin typeface="나눔고딕코딩"/>
-                <a:ea typeface="나눔고딕코딩"/>
-                <a:cs typeface="나눔고딕코딩"/>
-              </a:rPr>
-              <a:t>안녕 </a:t>
-            </a:r>
-            <a:r>
-              <a:rPr sz="2250" b="0">
-                <a:solidFill>
-                  <a:srgbClr val="8ABFFF"/>
-                </a:solidFill>
-                <a:latin typeface="나눔고딕코딩"/>
-                <a:ea typeface="나눔고딕코딩"/>
-                <a:cs typeface="나눔고딕코딩"/>
-              </a:rPr>
-              <a:t>&lt;strong</a:t>
-            </a:r>
-            <a:r>
-              <a:rPr sz="2250" b="0">
-                <a:solidFill>
-                  <a:srgbClr val="8ABFFF"/>
-                </a:solidFill>
-                <a:latin typeface="나눔고딕코딩"/>
-                <a:ea typeface="나눔고딕코딩"/>
-                <a:cs typeface="나눔고딕코딩"/>
-              </a:rPr>
-              <a:t>&gt;</a:t>
-            </a:r>
-            <a:r>
-              <a:rPr sz="2250" b="0">
-                <a:solidFill>
-                  <a:srgbClr val="E6EAF2"/>
-                </a:solidFill>
-                <a:latin typeface="나눔고딕코딩"/>
-                <a:ea typeface="나눔고딕코딩"/>
-                <a:cs typeface="나눔고딕코딩"/>
-              </a:rPr>
-              <a:t>반가워</a:t>
-            </a:r>
-            <a:r>
-              <a:rPr sz="2250" b="0">
-                <a:solidFill>
-                  <a:srgbClr val="8ABFFF"/>
-                </a:solidFill>
-                <a:latin typeface="나눔고딕코딩"/>
-                <a:ea typeface="나눔고딕코딩"/>
-                <a:cs typeface="나눔고딕코딩"/>
-              </a:rPr>
-              <a:t>&lt;/strong</a:t>
-            </a:r>
-            <a:r>
-              <a:rPr sz="2250" b="0">
-                <a:solidFill>
-                  <a:srgbClr val="8ABFFF"/>
-                </a:solidFill>
-                <a:latin typeface="나눔고딕코딩"/>
-                <a:ea typeface="나눔고딕코딩"/>
-                <a:cs typeface="나눔고딕코딩"/>
-              </a:rPr>
-              <a:t>&gt;</a:t>
-            </a:r>
-            <a:r>
-              <a:rPr sz="2250" b="0">
-                <a:solidFill>
-                  <a:srgbClr val="8ABFFF"/>
-                </a:solidFill>
-                <a:latin typeface="나눔고딕코딩"/>
-                <a:ea typeface="나눔고딕코딩"/>
-                <a:cs typeface="나눔고딕코딩"/>
-              </a:rPr>
-              <a:t>&lt;/p</a:t>
-            </a:r>
-            <a:r>
-              <a:rPr sz="2250" b="0">
-                <a:solidFill>
-                  <a:srgbClr val="8ABFFF"/>
-                </a:solidFill>
-                <a:latin typeface="나눔고딕코딩"/>
-                <a:ea typeface="나눔고딕코딩"/>
-                <a:cs typeface="나눔고딕코딩"/>
-              </a:rPr>
-              <a:t>&gt;</a:t>
-            </a:r>
-          </a:p>
-          <a:p>
-            <a:pPr algn="l">
-              <a:lnSpc>
-                <a:spcPct val="115000"/>
-              </a:lnSpc>
-            </a:pPr>
-            <a:r>
-              <a:rPr sz="2250" b="0">
-                <a:solidFill>
-                  <a:srgbClr val="E6EAF2"/>
-                </a:solidFill>
-                <a:latin typeface="나눔고딕코딩"/>
-                <a:ea typeface="나눔고딕코딩"/>
-                <a:cs typeface="나눔고딕코딩"/>
-              </a:rPr>
-              <a:t/>
-            </a:r>
-          </a:p>
-          <a:p>
-            <a:pPr algn="l">
-              <a:lnSpc>
-                <a:spcPct val="115000"/>
-              </a:lnSpc>
-            </a:pPr>
-            <a:r>
-              <a:rPr sz="2250" b="0">
-                <a:solidFill>
-                  <a:srgbClr val="E6EAF2"/>
-                </a:solidFill>
-                <a:latin typeface="나눔고딕코딩"/>
-                <a:ea typeface="나눔고딕코딩"/>
-                <a:cs typeface="나눔고딕코딩"/>
-              </a:rPr>
-              <a:t>/* p (요소 노드)</a:t>
-            </a:r>
-          </a:p>
-          <a:p>
-            <a:pPr algn="l">
-              <a:lnSpc>
-                <a:spcPct val="115000"/>
-              </a:lnSpc>
-            </a:pPr>
-            <a:r>
-              <a:rPr sz="2250" b="0">
-                <a:solidFill>
-                  <a:srgbClr val="E6EAF2"/>
-                </a:solidFill>
-                <a:latin typeface="나눔고딕코딩"/>
-                <a:ea typeface="나눔고딕코딩"/>
-                <a:cs typeface="나눔고딕코딩"/>
-              </a:rPr>
-              <a:t>   ├── </a:t>
-            </a:r>
-            <a:r>
-              <a:rPr sz="2250" b="0">
-                <a:solidFill>
-                  <a:srgbClr val="F5C97A"/>
-                </a:solidFill>
-                <a:latin typeface="나눔고딕코딩"/>
-                <a:ea typeface="나눔고딕코딩"/>
-                <a:cs typeface="나눔고딕코딩"/>
-              </a:rPr>
-              <a:t>"안녕 "</a:t>
-            </a:r>
-            <a:r>
-              <a:rPr sz="2250" b="0">
-                <a:solidFill>
-                  <a:srgbClr val="E6EAF2"/>
-                </a:solidFill>
-                <a:latin typeface="나눔고딕코딩"/>
-                <a:ea typeface="나눔고딕코딩"/>
-                <a:cs typeface="나눔고딕코딩"/>
-              </a:rPr>
-              <a:t>        (텍스트 노드)  ← 공백도 노드입니다</a:t>
-            </a:r>
-          </a:p>
-          <a:p>
-            <a:pPr algn="l">
-              <a:lnSpc>
-                <a:spcPct val="115000"/>
-              </a:lnSpc>
-            </a:pPr>
-            <a:r>
-              <a:rPr sz="2250" b="0">
-                <a:solidFill>
-                  <a:srgbClr val="E6EAF2"/>
-                </a:solidFill>
-                <a:latin typeface="나눔고딕코딩"/>
-                <a:ea typeface="나눔고딕코딩"/>
-                <a:cs typeface="나눔고딕코딩"/>
-              </a:rPr>
-              <a:t>   └── strong (요소 노드)</a:t>
-            </a:r>
-          </a:p>
-          <a:p>
-            <a:pPr algn="l">
-              <a:lnSpc>
-                <a:spcPct val="115000"/>
-              </a:lnSpc>
-            </a:pPr>
-            <a:r>
-              <a:rPr sz="2250" b="0">
-                <a:solidFill>
-                  <a:srgbClr val="E6EAF2"/>
-                </a:solidFill>
-                <a:latin typeface="나눔고딕코딩"/>
-                <a:ea typeface="나눔고딕코딩"/>
-                <a:cs typeface="나눔고딕코딩"/>
-              </a:rPr>
-              <a:t>       └── </a:t>
-            </a:r>
-            <a:r>
-              <a:rPr sz="2250" b="0">
-                <a:solidFill>
-                  <a:srgbClr val="F5C97A"/>
-                </a:solidFill>
-                <a:latin typeface="나눔고딕코딩"/>
-                <a:ea typeface="나눔고딕코딩"/>
-                <a:cs typeface="나눔고딕코딩"/>
-              </a:rPr>
-              <a:t>"반가워"</a:t>
-            </a:r>
-            <a:r>
-              <a:rPr sz="2250" b="0">
-                <a:solidFill>
-                  <a:srgbClr val="E6EAF2"/>
-                </a:solidFill>
-                <a:latin typeface="나눔고딕코딩"/>
-                <a:ea typeface="나눔고딕코딩"/>
-                <a:cs typeface="나눔고딕코딩"/>
-              </a:rPr>
-              <a:t>    (텍스트 노드)  */</a:t>
-            </a:r>
-          </a:p>
-          <a:p>
-            <a:pPr algn="l">
-              <a:lnSpc>
-                <a:spcPct val="115000"/>
-              </a:lnSpc>
-            </a:pPr>
-            <a:r>
-              <a:rPr sz="2250" b="0">
-                <a:solidFill>
-                  <a:srgbClr val="E6EAF2"/>
-                </a:solidFill>
-                <a:latin typeface="나눔고딕코딩"/>
-                <a:ea typeface="나눔고딕코딩"/>
-                <a:cs typeface="나눔고딕코딩"/>
-              </a:rPr>
-              <a:t/>
-            </a:r>
-          </a:p>
-          <a:p>
-            <a:pPr algn="l">
-              <a:lnSpc>
-                <a:spcPct val="115000"/>
-              </a:lnSpc>
-            </a:pPr>
-            <a:r>
-              <a:rPr sz="2250" b="0">
-                <a:solidFill>
-                  <a:srgbClr val="E6EAF2"/>
-                </a:solidFill>
-                <a:latin typeface="나눔고딕코딩"/>
-                <a:ea typeface="나눔고딕코딩"/>
-                <a:cs typeface="나눔고딕코딩"/>
-              </a:rPr>
-              <a:t>p.childNodes    // 텍스트 노드까지 전부 (공백 포함 — 자주 헷갈립니다)</a:t>
-            </a:r>
-          </a:p>
-          <a:p>
-            <a:pPr algn="l">
-              <a:lnSpc>
-                <a:spcPct val="115000"/>
-              </a:lnSpc>
-            </a:pPr>
-            <a:r>
-              <a:rPr sz="2250" b="0">
-                <a:solidFill>
-                  <a:srgbClr val="E6EAF2"/>
-                </a:solidFill>
-                <a:latin typeface="나눔고딕코딩"/>
-                <a:ea typeface="나눔고딕코딩"/>
-                <a:cs typeface="나눔고딕코딩"/>
-              </a:rPr>
-              <a:t>p.children      // 요소 노드만 (보통 이쪽을 씁니다)</a:t>
-            </a:r>
-          </a:p>
-        </p:txBody>
-      </p:sp>
+            <a:ext cx="8439150" cy="3557588"/>
+          </a:xfrm>
+          <a:prstGeom prst="rect">
+            <a:avLst/>
+          </a:prstGeom>
+        </p:spPr>
+      </p:pic>
       <p:sp>
         <p:nvSpPr>
           <p:cNvPr id="12" name="Rectangle 11"/>
@@ -11427,322 +11123,30 @@
           </a:p>
         </p:txBody>
       </p:sp>
-      <p:sp>
-        <p:nvSpPr>
-          <p:cNvPr id="11" name="deckgen:code"/>
-          <p:cNvSpPr txBox="1"/>
-          <p:nvPr/>
-        </p:nvSpPr>
+      <p:pic>
+        <p:nvPicPr>
+          <p:cNvPr id="11" name="deckgen:code-art" descr="image.png"/>
+          <p:cNvPicPr>
+            <a:picLocks noChangeAspect="1"/>
+          </p:cNvPicPr>
+          <p:nvPr/>
+        </p:nvPicPr>
+        <p:blipFill>
+          <a:blip r:embed="rId2"/>
+          <a:stretch>
+            <a:fillRect/>
+          </a:stretch>
+        </p:blipFill>
         <p:spPr>
           <a:xfrm>
             <a:off x="2038350" y="2552700"/>
-            <a:ext cx="14897100" cy="5105400"/>
-          </a:xfrm>
-          <a:prstGeom prst="rect">
-            <a:avLst/>
-          </a:prstGeom>
-          <a:noFill/>
-        </p:spPr>
-        <p:txBody>
-          <a:bodyPr wrap="none" lIns="0" rIns="0" tIns="0" bIns="0" anchor="t">
-            <a:spAutoFit/>
-          </a:bodyPr>
-          <a:lstStyle/>
-          <a:p>
-            <a:pPr algn="l">
-              <a:lnSpc>
-                <a:spcPct val="115000"/>
-              </a:lnSpc>
-            </a:pPr>
-            <a:r>
-              <a:rPr sz="2250" b="0">
-                <a:solidFill>
-                  <a:srgbClr val="E6EAF2"/>
-                </a:solidFill>
-                <a:latin typeface="나눔고딕코딩"/>
-                <a:ea typeface="나눔고딕코딩"/>
-                <a:cs typeface="나눔고딕코딩"/>
-              </a:rPr>
-              <a:t>document</a:t>
-            </a:r>
-          </a:p>
-          <a:p>
-            <a:pPr algn="l">
-              <a:lnSpc>
-                <a:spcPct val="115000"/>
-              </a:lnSpc>
-            </a:pPr>
-            <a:r>
-              <a:rPr sz="2250" b="0">
-                <a:solidFill>
-                  <a:srgbClr val="E6EAF2"/>
-                </a:solidFill>
-                <a:latin typeface="나눔고딕코딩"/>
-                <a:ea typeface="나눔고딕코딩"/>
-                <a:cs typeface="나눔고딕코딩"/>
-              </a:rPr>
-              <a:t>  └── body</a:t>
-            </a:r>
-          </a:p>
-          <a:p>
-            <a:pPr algn="l">
-              <a:lnSpc>
-                <a:spcPct val="115000"/>
-              </a:lnSpc>
-            </a:pPr>
-            <a:r>
-              <a:rPr sz="2250" b="0">
-                <a:solidFill>
-                  <a:srgbClr val="E6EAF2"/>
-                </a:solidFill>
-                <a:latin typeface="나눔고딕코딩"/>
-                <a:ea typeface="나눔고딕코딩"/>
-                <a:cs typeface="나눔고딕코딩"/>
-              </a:rPr>
-              <a:t>      └── ul            ② 타깃까지 내려가는 길 = 캡처링</a:t>
-            </a:r>
-          </a:p>
-          <a:p>
-            <a:pPr algn="l">
-              <a:lnSpc>
-                <a:spcPct val="115000"/>
-              </a:lnSpc>
-            </a:pPr>
-            <a:r>
-              <a:rPr sz="2250" b="0">
-                <a:solidFill>
-                  <a:srgbClr val="E6EAF2"/>
-                </a:solidFill>
-                <a:latin typeface="나눔고딕코딩"/>
-                <a:ea typeface="나눔고딕코딩"/>
-                <a:cs typeface="나눔고딕코딩"/>
-              </a:rPr>
-              <a:t>          └── li  ← 클릭한 곳 (타깃)</a:t>
-            </a:r>
-          </a:p>
-          <a:p>
-            <a:pPr algn="l">
-              <a:lnSpc>
-                <a:spcPct val="115000"/>
-              </a:lnSpc>
-            </a:pPr>
-            <a:r>
-              <a:rPr sz="2250" b="0">
-                <a:solidFill>
-                  <a:srgbClr val="E6EAF2"/>
-                </a:solidFill>
-                <a:latin typeface="나눔고딕코딩"/>
-                <a:ea typeface="나눔고딕코딩"/>
-                <a:cs typeface="나눔고딕코딩"/>
-              </a:rPr>
-              <a:t>      ↑                 ③ 다시 올라가는 길 = 버블링</a:t>
-            </a:r>
-          </a:p>
-          <a:p>
-            <a:pPr algn="l">
-              <a:lnSpc>
-                <a:spcPct val="115000"/>
-              </a:lnSpc>
-            </a:pPr>
-            <a:r>
-              <a:rPr sz="2250" b="0">
-                <a:solidFill>
-                  <a:srgbClr val="E6EAF2"/>
-                </a:solidFill>
-                <a:latin typeface="나눔고딕코딩"/>
-                <a:ea typeface="나눔고딕코딩"/>
-                <a:cs typeface="나눔고딕코딩"/>
-              </a:rPr>
-              <a:t/>
-            </a:r>
-          </a:p>
-          <a:p>
-            <a:pPr algn="l">
-              <a:lnSpc>
-                <a:spcPct val="115000"/>
-              </a:lnSpc>
-            </a:pPr>
-            <a:r>
-              <a:rPr sz="2250" b="0">
-                <a:solidFill>
-                  <a:srgbClr val="E6EAF2"/>
-                </a:solidFill>
-                <a:latin typeface="나눔고딕코딩"/>
-                <a:ea typeface="나눔고딕코딩"/>
-                <a:cs typeface="나눔고딕코딩"/>
-              </a:rPr>
-              <a:t>// 기본값은 버블링 단계에서 실행</a:t>
-            </a:r>
-          </a:p>
-          <a:p>
-            <a:pPr algn="l">
-              <a:lnSpc>
-                <a:spcPct val="115000"/>
-              </a:lnSpc>
-            </a:pPr>
-            <a:r>
-              <a:rPr sz="2250" b="0">
-                <a:solidFill>
-                  <a:srgbClr val="E6EAF2"/>
-                </a:solidFill>
-                <a:latin typeface="나눔고딕코딩"/>
-                <a:ea typeface="나눔고딕코딩"/>
-                <a:cs typeface="나눔고딕코딩"/>
-              </a:rPr>
-              <a:t>el.addEventListener(</a:t>
-            </a:r>
-            <a:r>
-              <a:rPr sz="2250" b="0">
-                <a:solidFill>
-                  <a:srgbClr val="F5C97A"/>
-                </a:solidFill>
-                <a:latin typeface="나눔고딕코딩"/>
-                <a:ea typeface="나눔고딕코딩"/>
-                <a:cs typeface="나눔고딕코딩"/>
-              </a:rPr>
-              <a:t>'click'</a:t>
-            </a:r>
-            <a:r>
-              <a:rPr sz="2250" b="0">
-                <a:solidFill>
-                  <a:srgbClr val="E6EAF2"/>
-                </a:solidFill>
-                <a:latin typeface="나눔고딕코딩"/>
-                <a:ea typeface="나눔고딕코딩"/>
-                <a:cs typeface="나눔고딕코딩"/>
-              </a:rPr>
-              <a:t>, fn);</a:t>
-            </a:r>
-          </a:p>
-          <a:p>
-            <a:pPr algn="l">
-              <a:lnSpc>
-                <a:spcPct val="115000"/>
-              </a:lnSpc>
-            </a:pPr>
-            <a:r>
-              <a:rPr sz="2250" b="0">
-                <a:solidFill>
-                  <a:srgbClr val="E6EAF2"/>
-                </a:solidFill>
-                <a:latin typeface="나눔고딕코딩"/>
-                <a:ea typeface="나눔고딕코딩"/>
-                <a:cs typeface="나눔고딕코딩"/>
-              </a:rPr>
-              <a:t/>
-            </a:r>
-          </a:p>
-          <a:p>
-            <a:pPr algn="l">
-              <a:lnSpc>
-                <a:spcPct val="115000"/>
-              </a:lnSpc>
-            </a:pPr>
-            <a:r>
-              <a:rPr sz="2250" b="0">
-                <a:solidFill>
-                  <a:srgbClr val="E6EAF2"/>
-                </a:solidFill>
-                <a:latin typeface="나눔고딕코딩"/>
-                <a:ea typeface="나눔고딕코딩"/>
-                <a:cs typeface="나눔고딕코딩"/>
-              </a:rPr>
-              <a:t>// 캡처링 단계에서 실행하려면</a:t>
-            </a:r>
-          </a:p>
-          <a:p>
-            <a:pPr algn="l">
-              <a:lnSpc>
-                <a:spcPct val="115000"/>
-              </a:lnSpc>
-            </a:pPr>
-            <a:r>
-              <a:rPr sz="2250" b="0">
-                <a:solidFill>
-                  <a:srgbClr val="E6EAF2"/>
-                </a:solidFill>
-                <a:latin typeface="나눔고딕코딩"/>
-                <a:ea typeface="나눔고딕코딩"/>
-                <a:cs typeface="나눔고딕코딩"/>
-              </a:rPr>
-              <a:t>el.addEventListener(</a:t>
-            </a:r>
-            <a:r>
-              <a:rPr sz="2250" b="0">
-                <a:solidFill>
-                  <a:srgbClr val="F5C97A"/>
-                </a:solidFill>
-                <a:latin typeface="나눔고딕코딩"/>
-                <a:ea typeface="나눔고딕코딩"/>
-                <a:cs typeface="나눔고딕코딩"/>
-              </a:rPr>
-              <a:t>'click'</a:t>
-            </a:r>
-            <a:r>
-              <a:rPr sz="2250" b="0">
-                <a:solidFill>
-                  <a:srgbClr val="E6EAF2"/>
-                </a:solidFill>
-                <a:latin typeface="나눔고딕코딩"/>
-                <a:ea typeface="나눔고딕코딩"/>
-                <a:cs typeface="나눔고딕코딩"/>
-              </a:rPr>
-              <a:t>, fn, true);</a:t>
-            </a:r>
-          </a:p>
-          <a:p>
-            <a:pPr algn="l">
-              <a:lnSpc>
-                <a:spcPct val="115000"/>
-              </a:lnSpc>
-            </a:pPr>
-            <a:r>
-              <a:rPr sz="2250" b="0">
-                <a:solidFill>
-                  <a:srgbClr val="8ABFFF"/>
-                </a:solidFill>
-                <a:latin typeface="나눔고딕코딩"/>
-                <a:ea typeface="나눔고딕코딩"/>
-                <a:cs typeface="나눔고딕코딩"/>
-              </a:rPr>
-              <a:t>el.addEventListener('click', fn, </a:t>
-            </a:r>
-            <a:r>
-              <a:rPr sz="2250" b="0">
-                <a:solidFill>
-                  <a:srgbClr val="E6EAF2"/>
-                </a:solidFill>
-                <a:latin typeface="나눔고딕코딩"/>
-                <a:ea typeface="나눔고딕코딩"/>
-                <a:cs typeface="나눔고딕코딩"/>
-              </a:rPr>
-              <a:t>{ </a:t>
-            </a:r>
-            <a:r>
-              <a:rPr sz="2250" b="0">
-                <a:solidFill>
-                  <a:srgbClr val="9FE8C0"/>
-                </a:solidFill>
-                <a:latin typeface="나눔고딕코딩"/>
-                <a:ea typeface="나눔고딕코딩"/>
-                <a:cs typeface="나눔고딕코딩"/>
-              </a:rPr>
-              <a:t>capture</a:t>
-            </a:r>
-            <a:r>
-              <a:rPr sz="2250" b="0">
-                <a:solidFill>
-                  <a:srgbClr val="E6EAF2"/>
-                </a:solidFill>
-                <a:latin typeface="나눔고딕코딩"/>
-                <a:ea typeface="나눔고딕코딩"/>
-                <a:cs typeface="나눔고딕코딩"/>
-              </a:rPr>
-              <a:t>: true });</a:t>
-            </a:r>
-          </a:p>
-        </p:txBody>
-      </p:sp>
+            <a:ext cx="7439025" cy="4743450"/>
+          </a:xfrm>
+          <a:prstGeom prst="rect">
+            <a:avLst/>
+          </a:prstGeom>
+        </p:spPr>
+      </p:pic>
       <p:sp>
         <p:nvSpPr>
           <p:cNvPr id="12" name="Rectangle 11"/>

</xml_diff>